<commit_message>
Integrity: make data-feed 'tell not show' — Data-freshness card is informational (no add-data button) with an integrity note; outcome logging in-memory only (no file). Update deck/video/pptx with new features + a demo-integrity rule (never modify the fixed dataset)
Co-Authored-By: Claude Opus 4.8 <noreply@anthropic.com>
</commit_message>
<xml_diff>
--- a/pitch/ParkPulse_Deck.pptx
+++ b/pitch/ParkPulse_Deck.pptx
@@ -3686,7 +3686,7 @@
                 </a:solidFill>
                 <a:latin typeface="Segoe UI"/>
               </a:rPr>
-              <a:t>Long-term · It compounds</a:t>
+              <a:t>By design · Live &amp; self-improving</a:t>
             </a:r>
           </a:p>
         </p:txBody>
@@ -3725,7 +3725,7 @@
                 </a:solidFill>
                 <a:latin typeface="Segoe UI"/>
               </a:rPr>
-              <a:t>It gets better every day</a:t>
+              <a:t>Live, explainable &amp; self-improving</a:t>
             </a:r>
           </a:p>
         </p:txBody>
@@ -3764,7 +3764,7 @@
                 </a:solidFill>
                 <a:latin typeface="Segoe UI"/>
               </a:rPr>
-              <a:t>•  Every new challan sharpens the forecast — a nightly refresh, no heavy retraining.</a:t>
+              <a:t>•  Explainable: tap any team → why it's placed (forecast, junction/main-road impact, trend).</a:t>
             </a:r>
           </a:p>
           <a:p>
@@ -3780,7 +3780,7 @@
                 </a:solidFill>
                 <a:latin typeface="Segoe UI"/>
               </a:rPr>
-              <a:t>•  Deploy in the evenings → new data → the blind spot fills itself.</a:t>
+              <a:t>•  Event-aware: auto-flags unusual days (festivals / match days) above the weekday norm.</a:t>
             </a:r>
           </a:p>
           <a:p>
@@ -3796,7 +3796,23 @@
                 </a:solidFill>
                 <a:latin typeface="Segoe UI"/>
               </a:rPr>
-              <a:t>•  Roadmap: Retrospective (today) → Nightly refresh → Live ASTraM / camera feed.</a:t>
+              <a:t>•  Self-improving: a live ingest endpoint cleans new challans + rebuilds models in seconds.</a:t>
+            </a:r>
+          </a:p>
+          <a:p>
+            <a:pPr algn="l">
+              <a:spcAft>
+                <a:spcPts val="1200"/>
+              </a:spcAft>
+            </a:pPr>
+            <a:r>
+              <a:rPr sz="1900" b="0">
+                <a:solidFill>
+                  <a:srgbClr val="E6E9EF"/>
+                </a:solidFill>
+                <a:latin typeface="Segoe UI"/>
+              </a:rPr>
+              <a:t>•  Integrity: we never modify the fixed competition dataset — ingest is architecture, not run on it.</a:t>
             </a:r>
           </a:p>
         </p:txBody>
@@ -6463,7 +6479,7 @@
                 </a:solidFill>
                 <a:latin typeface="Segoe UI"/>
               </a:rPr>
-              <a:t>•  One click → a spaced patrol plan + CSV for morning roll-call.</a:t>
+              <a:t>•  One click → a spaced patrol plan, shared by WhatsApp / print / CSV at roll-call.</a:t>
             </a:r>
           </a:p>
           <a:p>
@@ -6479,7 +6495,7 @@
                 </a:solidFill>
                 <a:latin typeface="Segoe UI"/>
               </a:rPr>
-              <a:t>•  Repeat-offender target lists (15% → 34%):</a:t>
+              <a:t>•  Explainable: tap any team for why it's placed (forecast load, impact, trend).</a:t>
             </a:r>
           </a:p>
           <a:p>
@@ -6495,7 +6511,7 @@
                 </a:solidFill>
                 <a:latin typeface="Segoe UI"/>
               </a:rPr>
-              <a:t>•  owner-notice / escalated-penalty / tow-priority CSV exports.</a:t>
+              <a:t>•  Repeat-offender target lists (15% → 34%): owner-notice / escalated / tow CSV.</a:t>
             </a:r>
           </a:p>
         </p:txBody>

</xml_diff>

<commit_message>
Pitch: main app = Next.js (Vercel) + FastAPI (Render); drop Streamlit
Reposition the architecture/links across all decks (PITCH_DECK, SUBMISSION_DECK,
GAMMA_DECK, DECK_FOR_AI, both pptx builders) so the product is presented as the
full-stack Next.js 16/React 19/deck.gl frontend on Vercel + FastAPI backend on
Render sharing app/core.py — no more Streamlit. Updated the Eraser architecture
diagram (removed the Streamlit node) and regenerated both PPTX + the diagram PNGs.

Co-Authored-By: Claude Opus 4.8 <noreply@anthropic.com>
Claude-Session: https://claude.ai/code/session_01Xr9DYnKWkghcBQLrU88Njx
</commit_message>
<xml_diff>
--- a/pitch/ParkPulse_Deck.pptx
+++ b/pitch/ParkPulse_Deck.pptx
@@ -4013,7 +4013,7 @@
                 </a:solidFill>
                 <a:latin typeface="Segoe UI"/>
               </a:rPr>
-              <a:t>Two front-ends, one brain — small, fast, explainable</a:t>
+              <a:t>One engine, two services — small, fast, explainable</a:t>
             </a:r>
           </a:p>
         </p:txBody>
@@ -4068,7 +4068,7 @@
                 </a:solidFill>
                 <a:latin typeface="Segoe UI"/>
               </a:rPr>
-              <a:t>•  Two apps share it: a live Streamlit demo + full-stack FastAPI (Render) &amp; Next.js 16 / React 19 / deck.gl (Vercel).</a:t>
+              <a:t>•  The product: Next.js 16 / React 19 / deck.gl frontend (Vercel) + FastAPI backend (Render) — both call the one engine.</a:t>
             </a:r>
           </a:p>
           <a:p>
@@ -4681,7 +4681,7 @@
                 </a:solidFill>
                 <a:latin typeface="Segoe UI"/>
               </a:rPr>
-              <a:t>Live demo: flipkart-gridlock-20-r2-rinxb9yibzp8knp6quhfew.streamlit.app</a:t>
+              <a:t>Live app: Next.js on Vercel + FastAPI on Render  ·  [Vercel URL]</a:t>
             </a:r>
           </a:p>
         </p:txBody>

</xml_diff>